<commit_message>
Kapacitātes plaisa, datu kvalitātes monitors, VID parādnieku loader
</commit_message>
<xml_diff>
--- a/IUB_prezentacija.pptx
+++ b/IUB_prezentacija.pptx
@@ -16,9 +16,10 @@
     <p:sldId id="264" r:id="rId10"/>
     <p:sldId id="265" r:id="rId11"/>
     <p:sldId id="266" r:id="rId12"/>
+    <p:sldId id="267" r:id="rId13"/>
   </p:sldIdLst>
   <p:notesMasterIdLst>
-    <p:notesMasterId r:id="rId13"/>
+    <p:notesMasterId r:id="rId14"/>
   </p:notesMasterIdLst>
   <p:sldSz cx="12192000" cy="6858000"/>
   <p:notesSz cx="6858000" cy="12192000"/>
@@ -688,7 +689,7 @@
           <a:p>
             <a:r>
               <a:rPr lang="en-US" dirty="0"/>
-              <a:t/>
+              <a:t>Šis ir spēcīgākais PEP arguments: lielākais risks ir radinieku firmās, un tieši tās neviens neredz, jo PNP reģistrs un deklarācijas nav atvērtajos datos. To atvēršana ir vērtīgākais solis.</a:t>
             </a:r>
             <a:endParaRPr lang="en-US" dirty="0"/>
           </a:p>
@@ -712,6 +713,94 @@
             <a:fld id="{F7021451-1387-4CA6-816F-3879F97B5CBC}" type="slidenum">
               <a:rPr lang="en-US"/>
               <a:t>11</a:t>
+            </a:fld>
+            <a:endParaRPr lang="en-US"/>
+          </a:p>
+        </p:txBody>
+      </p:sp>
+    </p:spTree>
+    <p:extLst>
+      <p:ext uri="{BB962C8B-B14F-4D97-AF65-F5344CB8AC3E}">
+        <p14:creationId xmlns:p14="http://schemas.microsoft.com/office/powerpoint/2010/main" val="1024086991"/>
+      </p:ext>
+    </p:extLst>
+  </p:cSld>
+  <p:clrMapOvr>
+    <a:masterClrMapping/>
+  </p:clrMapOvr>
+</p:notes>
+</file>
+
+<file path=ppt/notesSlides/notesSlide12.xml><?xml version="1.0" encoding="utf-8"?>
+<p:notes xmlns:a="http://schemas.openxmlformats.org/drawingml/2006/main" xmlns:r="http://schemas.openxmlformats.org/officeDocument/2006/relationships" xmlns:p="http://schemas.openxmlformats.org/presentationml/2006/main">
+  <p:cSld>
+    <p:spTree>
+      <p:nvGrpSpPr>
+        <p:cNvPr id="1" name=""/>
+        <p:cNvGrpSpPr/>
+        <p:nvPr/>
+      </p:nvGrpSpPr>
+      <p:grpSpPr>
+        <a:xfrm>
+          <a:off x="0" y="0"/>
+          <a:ext cx="0" cy="0"/>
+          <a:chOff x="0" y="0"/>
+          <a:chExt cx="0" cy="0"/>
+        </a:xfrm>
+      </p:grpSpPr>
+      <p:sp>
+        <p:nvSpPr>
+          <p:cNvPr id="2" name="Slide Image Placeholder 1"/>
+          <p:cNvSpPr>
+            <a:spLocks noGrp="1" noRot="1" noChangeAspect="1"/>
+          </p:cNvSpPr>
+          <p:nvPr>
+            <p:ph type="sldImg"/>
+          </p:nvPr>
+        </p:nvSpPr>
+        <p:spPr/>
+      </p:sp>
+      <p:sp>
+        <p:nvSpPr>
+          <p:cNvPr id="3" name="Notes Placeholder 2"/>
+          <p:cNvSpPr>
+            <a:spLocks noGrp="1"/>
+          </p:cNvSpPr>
+          <p:nvPr>
+            <p:ph type="body" idx="1"/>
+          </p:nvPr>
+        </p:nvSpPr>
+        <p:spPr/>
+        <p:txBody>
+          <a:bodyPr/>
+          <a:lstStyle/>
+          <a:p>
+            <a:r>
+              <a:rPr lang="en-US" dirty="0"/>
+              <a:t/>
+            </a:r>
+            <a:endParaRPr lang="en-US" dirty="0"/>
+          </a:p>
+        </p:txBody>
+      </p:sp>
+      <p:sp>
+        <p:nvSpPr>
+          <p:cNvPr id="4" name="Slide Number Placeholder 3"/>
+          <p:cNvSpPr>
+            <a:spLocks noGrp="1"/>
+          </p:cNvSpPr>
+          <p:nvPr>
+            <p:ph type="sldNum" sz="quarter" idx="10"/>
+          </p:nvPr>
+        </p:nvSpPr>
+        <p:spPr/>
+        <p:txBody>
+          <a:bodyPr/>
+          <a:lstStyle/>
+          <a:p>
+            <a:fld id="{F7021451-1387-4CA6-816F-3879F97B5CBC}" type="slidenum">
+              <a:rPr lang="en-US"/>
+              <a:t>12</a:t>
             </a:fld>
             <a:endParaRPr lang="en-US"/>
           </a:p>
@@ -2974,6 +3063,522 @@
 <file path=ppt/slides/slide11.xml><?xml version="1.0" encoding="utf-8"?>
 <p:sld xmlns:a="http://schemas.openxmlformats.org/drawingml/2006/main" xmlns:r="http://schemas.openxmlformats.org/officeDocument/2006/relationships" xmlns:p="http://schemas.openxmlformats.org/presentationml/2006/main">
   <p:cSld name="Slide 11">
+    <p:bg>
+      <p:bgPr>
+        <a:solidFill>
+          <a:srgbClr val="F4EFE6"/>
+        </a:solidFill>
+      </p:bgPr>
+    </p:bg>
+    <p:spTree>
+      <p:nvGrpSpPr>
+        <p:cNvPr id="1" name=""/>
+        <p:cNvGrpSpPr/>
+        <p:nvPr/>
+      </p:nvGrpSpPr>
+      <p:grpSpPr>
+        <a:xfrm>
+          <a:off x="0" y="0"/>
+          <a:ext cx="0" cy="0"/>
+          <a:chOff x="0" y="0"/>
+          <a:chExt cx="0" cy="0"/>
+        </a:xfrm>
+      </p:grpSpPr>
+      <p:sp>
+        <p:nvSpPr>
+          <p:cNvPr id="2" name="Text 0"/>
+          <p:cNvSpPr/>
+          <p:nvPr/>
+        </p:nvSpPr>
+        <p:spPr>
+          <a:xfrm>
+            <a:off x="548640" y="384048"/>
+            <a:ext cx="11064240" cy="566928"/>
+          </a:xfrm>
+          <a:prstGeom prst="rect">
+            <a:avLst/>
+          </a:prstGeom>
+          <a:noFill/>
+          <a:ln/>
+        </p:spPr>
+        <p:txBody>
+          <a:bodyPr wrap="square" lIns="0" tIns="0" rIns="0" bIns="0" rtlCol="0" anchor="ctr"/>
+          <a:lstStyle/>
+          <a:p>
+            <a:pPr indent="0" marL="0">
+              <a:buNone/>
+            </a:pPr>
+            <a:r>
+              <a:rPr lang="en-US" sz="3000" b="1" dirty="0">
+                <a:solidFill>
+                  <a:srgbClr val="1B2A24"/>
+                </a:solidFill>
+                <a:latin typeface="Cambria" pitchFamily="34" charset="0"/>
+                <a:ea typeface="Cambria" pitchFamily="34" charset="-122"/>
+                <a:cs typeface="Cambria" pitchFamily="34" charset="-120"/>
+              </a:rPr>
+              <a:t>Politiski nozīmīgas personas — un kur ir robs</a:t>
+            </a:r>
+            <a:endParaRPr lang="en-US" sz="3000" dirty="0"/>
+          </a:p>
+        </p:txBody>
+      </p:sp>
+      <p:sp>
+        <p:nvSpPr>
+          <p:cNvPr id="3" name="Text 1"/>
+          <p:cNvSpPr/>
+          <p:nvPr/>
+        </p:nvSpPr>
+        <p:spPr>
+          <a:xfrm>
+            <a:off x="548640" y="969264"/>
+            <a:ext cx="11064240" cy="329184"/>
+          </a:xfrm>
+          <a:prstGeom prst="rect">
+            <a:avLst/>
+          </a:prstGeom>
+          <a:noFill/>
+          <a:ln/>
+        </p:spPr>
+        <p:txBody>
+          <a:bodyPr wrap="square" lIns="0" tIns="0" rIns="0" bIns="0" rtlCol="0" anchor="ctr"/>
+          <a:lstStyle/>
+          <a:p>
+            <a:pPr indent="0" marL="0">
+              <a:buNone/>
+            </a:pPr>
+            <a:r>
+              <a:rPr lang="en-US" sz="1400" dirty="0">
+                <a:solidFill>
+                  <a:srgbClr val="6D645A"/>
+                </a:solidFill>
+                <a:latin typeface="Calibri" pitchFamily="34" charset="0"/>
+                <a:ea typeface="Calibri" pitchFamily="34" charset="-122"/>
+                <a:cs typeface="Calibri" pitchFamily="34" charset="-120"/>
+              </a:rPr>
+              <a:t>Vārda sakritība nav pierādījums. Neviena persona šeit nav nosaukta.</a:t>
+            </a:r>
+            <a:endParaRPr lang="en-US" sz="1400" dirty="0"/>
+          </a:p>
+        </p:txBody>
+      </p:sp>
+      <p:sp>
+        <p:nvSpPr>
+          <p:cNvPr id="4" name="Shape 2"/>
+          <p:cNvSpPr/>
+          <p:nvPr/>
+        </p:nvSpPr>
+        <p:spPr>
+          <a:xfrm>
+            <a:off x="548640" y="1600200"/>
+            <a:ext cx="5394960" cy="3246120"/>
+          </a:xfrm>
+          <a:prstGeom prst="roundRect">
+            <a:avLst>
+              <a:gd name="adj" fmla="val 2817"/>
+            </a:avLst>
+          </a:prstGeom>
+          <a:solidFill>
+            <a:srgbClr val="E3EFE9"/>
+          </a:solidFill>
+          <a:ln w="12700">
+            <a:solidFill>
+              <a:srgbClr val="E7DED0"/>
+            </a:solidFill>
+            <a:prstDash val="solid"/>
+          </a:ln>
+        </p:spPr>
+      </p:sp>
+      <p:sp>
+        <p:nvSpPr>
+          <p:cNvPr id="5" name="Text 3"/>
+          <p:cNvSpPr/>
+          <p:nvPr/>
+        </p:nvSpPr>
+        <p:spPr>
+          <a:xfrm>
+            <a:off x="868680" y="1828800"/>
+            <a:ext cx="4754880" cy="320040"/>
+          </a:xfrm>
+          <a:prstGeom prst="rect">
+            <a:avLst/>
+          </a:prstGeom>
+          <a:noFill/>
+          <a:ln/>
+        </p:spPr>
+        <p:txBody>
+          <a:bodyPr wrap="square" rtlCol="0" anchor="ctr"/>
+          <a:lstStyle/>
+          <a:p>
+            <a:pPr indent="0" marL="0">
+              <a:buNone/>
+            </a:pPr>
+            <a:r>
+              <a:rPr lang="en-US" sz="1200" b="1" spc="100" kern="0" dirty="0">
+                <a:solidFill>
+                  <a:srgbClr val="1F7A5F"/>
+                </a:solidFill>
+                <a:latin typeface="Calibri" pitchFamily="34" charset="0"/>
+                <a:ea typeface="Calibri" pitchFamily="34" charset="-122"/>
+                <a:cs typeface="Calibri" pitchFamily="34" charset="-120"/>
+              </a:rPr>
+              <a:t>KO JAU VARAM</a:t>
+            </a:r>
+            <a:endParaRPr lang="en-US" sz="1200" dirty="0"/>
+          </a:p>
+        </p:txBody>
+      </p:sp>
+      <p:sp>
+        <p:nvSpPr>
+          <p:cNvPr id="6" name="Text 4"/>
+          <p:cNvSpPr/>
+          <p:nvPr/>
+        </p:nvSpPr>
+        <p:spPr>
+          <a:xfrm>
+            <a:off x="868680" y="2286000"/>
+            <a:ext cx="4754880" cy="2377440"/>
+          </a:xfrm>
+          <a:prstGeom prst="rect">
+            <a:avLst/>
+          </a:prstGeom>
+          <a:noFill/>
+          <a:ln/>
+        </p:spPr>
+        <p:txBody>
+          <a:bodyPr wrap="square" lIns="0" tIns="0" rIns="0" bIns="0" rtlCol="0" anchor="t"/>
+          <a:lstStyle/>
+          <a:p>
+            <a:pPr marL="342900" indent="-342900">
+              <a:lnSpc>
+                <a:spcPts val="1800"/>
+              </a:lnSpc>
+              <a:spcAft>
+                <a:spcPts val="1000"/>
+              </a:spcAft>
+              <a:buSzPct val="100000"/>
+              <a:buChar char="•"/>
+            </a:pPr>
+            <a:r>
+              <a:rPr lang="en-US" sz="1350" dirty="0">
+                <a:solidFill>
+                  <a:srgbClr val="1B2A24"/>
+                </a:solidFill>
+                <a:latin typeface="Calibri" pitchFamily="34" charset="0"/>
+                <a:ea typeface="Calibri" pitchFamily="34" charset="-122"/>
+                <a:cs typeface="Calibri" pitchFamily="34" charset="-120"/>
+              </a:rPr>
+              <a:t>Salīdzināt iepirkumu firmu īpašniekus ar amatpersonām — Ministru kabinets, Saeima, EP deputāti (CVK atvērtie dati)</a:t>
+            </a:r>
+            <a:endParaRPr lang="en-US" sz="1350" dirty="0"/>
+          </a:p>
+          <a:p>
+            <a:pPr marL="342900" indent="-342900">
+              <a:lnSpc>
+                <a:spcPts val="1800"/>
+              </a:lnSpc>
+              <a:spcAft>
+                <a:spcPts val="1000"/>
+              </a:spcAft>
+              <a:buSzPct val="100000"/>
+              <a:buChar char="•"/>
+            </a:pPr>
+            <a:r>
+              <a:rPr lang="en-US" sz="1350" dirty="0">
+                <a:solidFill>
+                  <a:srgbClr val="1B2A24"/>
+                </a:solidFill>
+                <a:latin typeface="Calibri" pitchFamily="34" charset="0"/>
+                <a:ea typeface="Calibri" pitchFamily="34" charset="-122"/>
+                <a:cs typeface="Calibri" pitchFamily="34" charset="-120"/>
+              </a:rPr>
+              <a:t>Atzīmēt sakritību ar godīgu atrunu un saiti pārbaudei</a:t>
+            </a:r>
+            <a:endParaRPr lang="en-US" sz="1350" dirty="0"/>
+          </a:p>
+          <a:p>
+            <a:pPr marL="342900" indent="-342900">
+              <a:lnSpc>
+                <a:spcPts val="1800"/>
+              </a:lnSpc>
+              <a:spcAft>
+                <a:spcPts val="1000"/>
+              </a:spcAft>
+              <a:buSzPct val="100000"/>
+              <a:buChar char="•"/>
+            </a:pPr>
+            <a:r>
+              <a:rPr lang="en-US" sz="1350" dirty="0">
+                <a:solidFill>
+                  <a:srgbClr val="1B2A24"/>
+                </a:solidFill>
+                <a:latin typeface="Calibri" pitchFamily="34" charset="0"/>
+                <a:ea typeface="Calibri" pitchFamily="34" charset="-122"/>
+                <a:cs typeface="Calibri" pitchFamily="34" charset="-120"/>
+              </a:rPr>
+              <a:t>Redzēt strukturālas saiknes: kopīgs īpašnieks vai holdings</a:t>
+            </a:r>
+            <a:endParaRPr lang="en-US" sz="1350" dirty="0"/>
+          </a:p>
+        </p:txBody>
+      </p:sp>
+      <p:sp>
+        <p:nvSpPr>
+          <p:cNvPr id="7" name="Shape 5"/>
+          <p:cNvSpPr/>
+          <p:nvPr/>
+        </p:nvSpPr>
+        <p:spPr>
+          <a:xfrm>
+            <a:off x="6263640" y="1600200"/>
+            <a:ext cx="5349240" cy="3246120"/>
+          </a:xfrm>
+          <a:prstGeom prst="roundRect">
+            <a:avLst>
+              <a:gd name="adj" fmla="val 2817"/>
+            </a:avLst>
+          </a:prstGeom>
+          <a:solidFill>
+            <a:srgbClr val="FBE2DD"/>
+          </a:solidFill>
+          <a:ln w="12700">
+            <a:solidFill>
+              <a:srgbClr val="E7DED0"/>
+            </a:solidFill>
+            <a:prstDash val="solid"/>
+          </a:ln>
+        </p:spPr>
+      </p:sp>
+      <p:sp>
+        <p:nvSpPr>
+          <p:cNvPr id="8" name="Text 6"/>
+          <p:cNvSpPr/>
+          <p:nvPr/>
+        </p:nvSpPr>
+        <p:spPr>
+          <a:xfrm>
+            <a:off x="6583680" y="1828800"/>
+            <a:ext cx="4846320" cy="320040"/>
+          </a:xfrm>
+          <a:prstGeom prst="rect">
+            <a:avLst/>
+          </a:prstGeom>
+          <a:noFill/>
+          <a:ln/>
+        </p:spPr>
+        <p:txBody>
+          <a:bodyPr wrap="square" rtlCol="0" anchor="ctr"/>
+          <a:lstStyle/>
+          <a:p>
+            <a:pPr indent="0" marL="0">
+              <a:buNone/>
+            </a:pPr>
+            <a:r>
+              <a:rPr lang="en-US" sz="1200" b="1" spc="100" kern="0" dirty="0">
+                <a:solidFill>
+                  <a:srgbClr val="B23420"/>
+                </a:solidFill>
+                <a:latin typeface="Calibri" pitchFamily="34" charset="0"/>
+                <a:ea typeface="Calibri" pitchFamily="34" charset="-122"/>
+                <a:cs typeface="Calibri" pitchFamily="34" charset="-120"/>
+              </a:rPr>
+              <a:t>KO NEVARAM — UN KUR IR RISKS</a:t>
+            </a:r>
+            <a:endParaRPr lang="en-US" sz="1200" dirty="0"/>
+          </a:p>
+        </p:txBody>
+      </p:sp>
+      <p:sp>
+        <p:nvSpPr>
+          <p:cNvPr id="9" name="Text 7"/>
+          <p:cNvSpPr/>
+          <p:nvPr/>
+        </p:nvSpPr>
+        <p:spPr>
+          <a:xfrm>
+            <a:off x="6583680" y="2286000"/>
+            <a:ext cx="4754880" cy="2377440"/>
+          </a:xfrm>
+          <a:prstGeom prst="rect">
+            <a:avLst/>
+          </a:prstGeom>
+          <a:noFill/>
+          <a:ln/>
+        </p:spPr>
+        <p:txBody>
+          <a:bodyPr wrap="square" lIns="0" tIns="0" rIns="0" bIns="0" rtlCol="0" anchor="t"/>
+          <a:lstStyle/>
+          <a:p>
+            <a:pPr marL="342900" indent="-342900">
+              <a:lnSpc>
+                <a:spcPts val="1800"/>
+              </a:lnSpc>
+              <a:spcAft>
+                <a:spcPts val="1000"/>
+              </a:spcAft>
+              <a:buSzPct val="100000"/>
+              <a:buChar char="•"/>
+            </a:pPr>
+            <a:r>
+              <a:rPr lang="en-US" sz="1350" dirty="0">
+                <a:solidFill>
+                  <a:srgbClr val="1B2A24"/>
+                </a:solidFill>
+                <a:latin typeface="Calibri" pitchFamily="34" charset="0"/>
+                <a:ea typeface="Calibri" pitchFamily="34" charset="-122"/>
+                <a:cs typeface="Calibri" pitchFamily="34" charset="-120"/>
+              </a:rPr>
+              <a:t>Amatpersonu RADINIEKU un darījumu partneru firmas — tieši tur slēpjas lielākais risks</a:t>
+            </a:r>
+            <a:endParaRPr lang="en-US" sz="1350" dirty="0"/>
+          </a:p>
+          <a:p>
+            <a:pPr marL="342900" indent="-342900">
+              <a:lnSpc>
+                <a:spcPts val="1800"/>
+              </a:lnSpc>
+              <a:spcAft>
+                <a:spcPts val="1000"/>
+              </a:spcAft>
+              <a:buSzPct val="100000"/>
+              <a:buChar char="•"/>
+            </a:pPr>
+            <a:r>
+              <a:rPr lang="en-US" sz="1350" dirty="0">
+                <a:solidFill>
+                  <a:srgbClr val="1B2A24"/>
+                </a:solidFill>
+                <a:latin typeface="Calibri" pitchFamily="34" charset="0"/>
+                <a:ea typeface="Calibri" pitchFamily="34" charset="-122"/>
+                <a:cs typeface="Calibri" pitchFamily="34" charset="-120"/>
+              </a:rPr>
+              <a:t>Pilns PEP loks ar personas kodu (bez vārdamāsu kļūdām)</a:t>
+            </a:r>
+            <a:endParaRPr lang="en-US" sz="1350" dirty="0"/>
+          </a:p>
+          <a:p>
+            <a:pPr marL="342900" indent="-342900">
+              <a:lnSpc>
+                <a:spcPts val="1800"/>
+              </a:lnSpc>
+              <a:spcAft>
+                <a:spcPts val="1000"/>
+              </a:spcAft>
+              <a:buSzPct val="100000"/>
+              <a:buChar char="•"/>
+            </a:pPr>
+            <a:r>
+              <a:rPr lang="en-US" sz="1350" dirty="0">
+                <a:solidFill>
+                  <a:srgbClr val="1B2A24"/>
+                </a:solidFill>
+                <a:latin typeface="Calibri" pitchFamily="34" charset="0"/>
+                <a:ea typeface="Calibri" pitchFamily="34" charset="-122"/>
+                <a:cs typeface="Calibri" pitchFamily="34" charset="-120"/>
+              </a:rPr>
+              <a:t>Valsts sekretāri, iestāžu un kapitālsabiedrību vadītāji, pašvaldību deputāti</a:t>
+            </a:r>
+            <a:endParaRPr lang="en-US" sz="1350" dirty="0"/>
+          </a:p>
+        </p:txBody>
+      </p:sp>
+      <p:sp>
+        <p:nvSpPr>
+          <p:cNvPr id="10" name="Shape 8"/>
+          <p:cNvSpPr/>
+          <p:nvPr/>
+        </p:nvSpPr>
+        <p:spPr>
+          <a:xfrm>
+            <a:off x="548640" y="5029200"/>
+            <a:ext cx="11064240" cy="1143000"/>
+          </a:xfrm>
+          <a:prstGeom prst="roundRect">
+            <a:avLst>
+              <a:gd name="adj" fmla="val 8000"/>
+            </a:avLst>
+          </a:prstGeom>
+          <a:solidFill>
+            <a:srgbClr val="FFFFFF"/>
+          </a:solidFill>
+          <a:ln w="12700">
+            <a:solidFill>
+              <a:srgbClr val="E7DED0"/>
+            </a:solidFill>
+            <a:prstDash val="solid"/>
+          </a:ln>
+        </p:spPr>
+      </p:sp>
+      <p:sp>
+        <p:nvSpPr>
+          <p:cNvPr id="11" name="Text 9"/>
+          <p:cNvSpPr/>
+          <p:nvPr/>
+        </p:nvSpPr>
+        <p:spPr>
+          <a:xfrm>
+            <a:off x="868680" y="5138928"/>
+            <a:ext cx="10424160" cy="914400"/>
+          </a:xfrm>
+          <a:prstGeom prst="rect">
+            <a:avLst/>
+          </a:prstGeom>
+          <a:noFill/>
+          <a:ln/>
+        </p:spPr>
+        <p:txBody>
+          <a:bodyPr wrap="square" lIns="0" tIns="0" rIns="0" bIns="0" rtlCol="0" anchor="ctr"/>
+          <a:lstStyle/>
+          <a:p>
+            <a:pPr indent="0" marL="0">
+              <a:lnSpc>
+                <a:spcPts val="1800"/>
+              </a:lnSpc>
+              <a:buNone/>
+            </a:pPr>
+            <a:r>
+              <a:rPr lang="en-US" sz="1400" b="1" dirty="0">
+                <a:solidFill>
+                  <a:srgbClr val="B23420"/>
+                </a:solidFill>
+                <a:latin typeface="Calibri" pitchFamily="34" charset="0"/>
+                <a:ea typeface="Calibri" pitchFamily="34" charset="-122"/>
+                <a:cs typeface="Calibri" pitchFamily="34" charset="-120"/>
+              </a:rPr>
+              <a:t>Kāpēc nevaram: </a:t>
+            </a:r>
+            <a:pPr indent="0" marL="0">
+              <a:lnSpc>
+                <a:spcPts val="1800"/>
+              </a:lnSpc>
+              <a:buNone/>
+            </a:pPr>
+            <a:r>
+              <a:rPr lang="en-US" sz="1400" dirty="0">
+                <a:solidFill>
+                  <a:srgbClr val="1B2A24"/>
+                </a:solidFill>
+                <a:latin typeface="Calibri" pitchFamily="34" charset="0"/>
+                <a:ea typeface="Calibri" pitchFamily="34" charset="-122"/>
+                <a:cs typeface="Calibri" pitchFamily="34" charset="-120"/>
+              </a:rPr>
+              <a:t>ne VID politiski nozīmīgu personu reģistrs, ne amatpersonu deklarācijas nav pieejamas mašīnlasāmā, atkalizmantojamā formā — tikai meklēšana pa vienam, ar personas kodu. Uzminēt radinieku pēc uzvārda būtu apmelojums, tāpēc to nedarām. Šo saikni šobrīd nevar redzēt neviens ārpus KNAB.</a:t>
+            </a:r>
+            <a:endParaRPr lang="en-US" sz="1400" dirty="0"/>
+          </a:p>
+        </p:txBody>
+      </p:sp>
+    </p:spTree>
+  </p:cSld>
+  <p:clrMapOvr>
+    <a:masterClrMapping/>
+  </p:clrMapOvr>
+</p:sld>
+</file>
+
+<file path=ppt/slides/slide12.xml><?xml version="1.0" encoding="utf-8"?>
+<p:sld xmlns:a="http://schemas.openxmlformats.org/drawingml/2006/main" xmlns:r="http://schemas.openxmlformats.org/officeDocument/2006/relationships" xmlns:p="http://schemas.openxmlformats.org/presentationml/2006/main">
+  <p:cSld name="Slide 12">
     <p:bg>
       <p:bgPr>
         <a:solidFill>

</xml_diff>